<commit_message>
Include avatar in slides
</commit_message>
<xml_diff>
--- a/apps/md-backend/src/main/resources/templates/1st_place_3j.pptx
+++ b/apps/md-backend/src/main/resources/templates/1st_place_3j.pptx
@@ -261,7 +261,7 @@
           <a:p>
             <a:fld id="{45F062A3-8868-478A-95F9-B75BA86CF6E5}" type="datetimeFigureOut">
               <a:rPr lang="es-PE" smtClean="0"/>
-              <a:t>21/07/2026</a:t>
+              <a:t>25/07/2026</a:t>
             </a:fld>
             <a:endParaRPr lang="es-PE"/>
           </a:p>
@@ -461,7 +461,7 @@
           <a:p>
             <a:fld id="{45F062A3-8868-478A-95F9-B75BA86CF6E5}" type="datetimeFigureOut">
               <a:rPr lang="es-PE" smtClean="0"/>
-              <a:t>21/07/2026</a:t>
+              <a:t>25/07/2026</a:t>
             </a:fld>
             <a:endParaRPr lang="es-PE"/>
           </a:p>
@@ -671,7 +671,7 @@
           <a:p>
             <a:fld id="{45F062A3-8868-478A-95F9-B75BA86CF6E5}" type="datetimeFigureOut">
               <a:rPr lang="es-PE" smtClean="0"/>
-              <a:t>21/07/2026</a:t>
+              <a:t>25/07/2026</a:t>
             </a:fld>
             <a:endParaRPr lang="es-PE"/>
           </a:p>
@@ -871,7 +871,7 @@
           <a:p>
             <a:fld id="{45F062A3-8868-478A-95F9-B75BA86CF6E5}" type="datetimeFigureOut">
               <a:rPr lang="es-PE" smtClean="0"/>
-              <a:t>21/07/2026</a:t>
+              <a:t>25/07/2026</a:t>
             </a:fld>
             <a:endParaRPr lang="es-PE"/>
           </a:p>
@@ -1147,7 +1147,7 @@
           <a:p>
             <a:fld id="{45F062A3-8868-478A-95F9-B75BA86CF6E5}" type="datetimeFigureOut">
               <a:rPr lang="es-PE" smtClean="0"/>
-              <a:t>21/07/2026</a:t>
+              <a:t>25/07/2026</a:t>
             </a:fld>
             <a:endParaRPr lang="es-PE"/>
           </a:p>
@@ -1415,7 +1415,7 @@
           <a:p>
             <a:fld id="{45F062A3-8868-478A-95F9-B75BA86CF6E5}" type="datetimeFigureOut">
               <a:rPr lang="es-PE" smtClean="0"/>
-              <a:t>21/07/2026</a:t>
+              <a:t>25/07/2026</a:t>
             </a:fld>
             <a:endParaRPr lang="es-PE"/>
           </a:p>
@@ -1830,7 +1830,7 @@
           <a:p>
             <a:fld id="{45F062A3-8868-478A-95F9-B75BA86CF6E5}" type="datetimeFigureOut">
               <a:rPr lang="es-PE" smtClean="0"/>
-              <a:t>21/07/2026</a:t>
+              <a:t>25/07/2026</a:t>
             </a:fld>
             <a:endParaRPr lang="es-PE"/>
           </a:p>
@@ -1972,7 +1972,7 @@
           <a:p>
             <a:fld id="{45F062A3-8868-478A-95F9-B75BA86CF6E5}" type="datetimeFigureOut">
               <a:rPr lang="es-PE" smtClean="0"/>
-              <a:t>21/07/2026</a:t>
+              <a:t>25/07/2026</a:t>
             </a:fld>
             <a:endParaRPr lang="es-PE"/>
           </a:p>
@@ -2085,7 +2085,7 @@
           <a:p>
             <a:fld id="{45F062A3-8868-478A-95F9-B75BA86CF6E5}" type="datetimeFigureOut">
               <a:rPr lang="es-PE" smtClean="0"/>
-              <a:t>21/07/2026</a:t>
+              <a:t>25/07/2026</a:t>
             </a:fld>
             <a:endParaRPr lang="es-PE"/>
           </a:p>
@@ -2398,7 +2398,7 @@
           <a:p>
             <a:fld id="{45F062A3-8868-478A-95F9-B75BA86CF6E5}" type="datetimeFigureOut">
               <a:rPr lang="es-PE" smtClean="0"/>
-              <a:t>21/07/2026</a:t>
+              <a:t>25/07/2026</a:t>
             </a:fld>
             <a:endParaRPr lang="es-PE"/>
           </a:p>
@@ -2687,7 +2687,7 @@
           <a:p>
             <a:fld id="{45F062A3-8868-478A-95F9-B75BA86CF6E5}" type="datetimeFigureOut">
               <a:rPr lang="es-PE" smtClean="0"/>
-              <a:t>21/07/2026</a:t>
+              <a:t>25/07/2026</a:t>
             </a:fld>
             <a:endParaRPr lang="es-PE"/>
           </a:p>
@@ -2930,7 +2930,7 @@
           <a:p>
             <a:fld id="{45F062A3-8868-478A-95F9-B75BA86CF6E5}" type="datetimeFigureOut">
               <a:rPr lang="es-PE" smtClean="0"/>
-              <a:t>21/07/2026</a:t>
+              <a:t>25/07/2026</a:t>
             </a:fld>
             <a:endParaRPr lang="es-PE"/>
           </a:p>
@@ -3486,65 +3486,6 @@
       </p:sp>
       <p:sp>
         <p:nvSpPr>
-          <p:cNvPr id="5" name="Rectangle: Rounded Corners 4">
-            <a:extLst>
-              <a:ext uri="{FF2B5EF4-FFF2-40B4-BE49-F238E27FC236}">
-                <a16:creationId xmlns:a16="http://schemas.microsoft.com/office/drawing/2014/main" id="{DEB568AF-09CB-168F-F1ED-2A5B613F04C7}"/>
-              </a:ext>
-            </a:extLst>
-          </p:cNvPr>
-          <p:cNvSpPr/>
-          <p:nvPr/>
-        </p:nvSpPr>
-        <p:spPr>
-          <a:xfrm>
-            <a:off x="455054" y="455054"/>
-            <a:ext cx="1632623" cy="953478"/>
-          </a:xfrm>
-          <a:prstGeom prst="roundRect">
-            <a:avLst>
-              <a:gd name="adj" fmla="val 50000"/>
-            </a:avLst>
-          </a:prstGeom>
-          <a:solidFill>
-            <a:srgbClr val="000000">
-              <a:alpha val="30196"/>
-            </a:srgbClr>
-          </a:solidFill>
-          <a:ln>
-            <a:noFill/>
-          </a:ln>
-        </p:spPr>
-        <p:style>
-          <a:lnRef idx="2">
-            <a:schemeClr val="accent1">
-              <a:shade val="50000"/>
-            </a:schemeClr>
-          </a:lnRef>
-          <a:fillRef idx="1">
-            <a:schemeClr val="accent1"/>
-          </a:fillRef>
-          <a:effectRef idx="0">
-            <a:schemeClr val="accent1"/>
-          </a:effectRef>
-          <a:fontRef idx="minor">
-            <a:schemeClr val="lt1"/>
-          </a:fontRef>
-        </p:style>
-        <p:txBody>
-          <a:bodyPr rtlCol="0" anchor="ctr"/>
-          <a:lstStyle/>
-          <a:p>
-            <a:pPr algn="ctr"/>
-            <a:r>
-              <a:rPr lang="es-PE" sz="3600" b="1" dirty="0"/>
-              <a:t>#{p}</a:t>
-            </a:r>
-          </a:p>
-        </p:txBody>
-      </p:sp>
-      <p:sp>
-        <p:nvSpPr>
           <p:cNvPr id="8" name="Rectangle: Rounded Corners 7">
             <a:extLst>
               <a:ext uri="{FF2B5EF4-FFF2-40B4-BE49-F238E27FC236}">
@@ -4364,6 +4305,62 @@
       </p:sp>
       <p:sp>
         <p:nvSpPr>
+          <p:cNvPr id="4" name="Rectangle: Rounded Corners 3">
+            <a:extLst>
+              <a:ext uri="{FF2B5EF4-FFF2-40B4-BE49-F238E27FC236}">
+                <a16:creationId xmlns:a16="http://schemas.microsoft.com/office/drawing/2014/main" id="{7783AEF4-CA3F-3A3B-824C-B45678D3BAF3}"/>
+              </a:ext>
+            </a:extLst>
+          </p:cNvPr>
+          <p:cNvSpPr/>
+          <p:nvPr/>
+        </p:nvSpPr>
+        <p:spPr>
+          <a:xfrm>
+            <a:off x="455053" y="455054"/>
+            <a:ext cx="2586624" cy="953478"/>
+          </a:xfrm>
+          <a:prstGeom prst="roundRect">
+            <a:avLst>
+              <a:gd name="adj" fmla="val 50000"/>
+            </a:avLst>
+          </a:prstGeom>
+          <a:solidFill>
+            <a:srgbClr val="000000">
+              <a:alpha val="30196"/>
+            </a:srgbClr>
+          </a:solidFill>
+          <a:ln>
+            <a:noFill/>
+          </a:ln>
+        </p:spPr>
+        <p:style>
+          <a:lnRef idx="2">
+            <a:schemeClr val="accent1">
+              <a:shade val="50000"/>
+            </a:schemeClr>
+          </a:lnRef>
+          <a:fillRef idx="1">
+            <a:schemeClr val="accent1"/>
+          </a:fillRef>
+          <a:effectRef idx="0">
+            <a:schemeClr val="accent1"/>
+          </a:effectRef>
+          <a:fontRef idx="minor">
+            <a:schemeClr val="lt1"/>
+          </a:fontRef>
+        </p:style>
+        <p:txBody>
+          <a:bodyPr rtlCol="0" anchor="ctr"/>
+          <a:lstStyle/>
+          <a:p>
+            <a:pPr algn="ctr"/>
+            <a:endParaRPr lang="es-PE" sz="3600" b="1" dirty="0"/>
+          </a:p>
+        </p:txBody>
+      </p:sp>
+      <p:sp>
+        <p:nvSpPr>
           <p:cNvPr id="42" name="Rectangle 41">
             <a:extLst>
               <a:ext uri="{FF2B5EF4-FFF2-40B4-BE49-F238E27FC236}">
@@ -4464,6 +4461,101 @@
             <a:r>
               <a:rPr lang="es-PE" sz="1600" dirty="0"/>
               <a:t>{review3}</a:t>
+            </a:r>
+          </a:p>
+        </p:txBody>
+      </p:sp>
+      <p:sp>
+        <p:nvSpPr>
+          <p:cNvPr id="5" name="Rectangle: Rounded Corners 4">
+            <a:extLst>
+              <a:ext uri="{FF2B5EF4-FFF2-40B4-BE49-F238E27FC236}">
+                <a16:creationId xmlns:a16="http://schemas.microsoft.com/office/drawing/2014/main" id="{DEB568AF-09CB-168F-F1ED-2A5B613F04C7}"/>
+              </a:ext>
+            </a:extLst>
+          </p:cNvPr>
+          <p:cNvSpPr/>
+          <p:nvPr/>
+        </p:nvSpPr>
+        <p:spPr>
+          <a:xfrm>
+            <a:off x="455054" y="455054"/>
+            <a:ext cx="1632623" cy="953478"/>
+          </a:xfrm>
+          <a:prstGeom prst="roundRect">
+            <a:avLst>
+              <a:gd name="adj" fmla="val 50000"/>
+            </a:avLst>
+          </a:prstGeom>
+          <a:noFill/>
+          <a:ln>
+            <a:noFill/>
+          </a:ln>
+        </p:spPr>
+        <p:style>
+          <a:lnRef idx="2">
+            <a:schemeClr val="accent1">
+              <a:shade val="50000"/>
+            </a:schemeClr>
+          </a:lnRef>
+          <a:fillRef idx="1">
+            <a:schemeClr val="accent1"/>
+          </a:fillRef>
+          <a:effectRef idx="0">
+            <a:schemeClr val="accent1"/>
+          </a:effectRef>
+          <a:fontRef idx="minor">
+            <a:schemeClr val="lt1"/>
+          </a:fontRef>
+        </p:style>
+        <p:txBody>
+          <a:bodyPr rtlCol="0" anchor="ctr"/>
+          <a:lstStyle/>
+          <a:p>
+            <a:pPr algn="ctr"/>
+            <a:r>
+              <a:rPr lang="es-PE" sz="3600" b="1" dirty="0"/>
+              <a:t>#{p}</a:t>
+            </a:r>
+          </a:p>
+        </p:txBody>
+      </p:sp>
+      <p:sp>
+        <p:nvSpPr>
+          <p:cNvPr id="3" name="TextBox 2">
+            <a:extLst>
+              <a:ext uri="{FF2B5EF4-FFF2-40B4-BE49-F238E27FC236}">
+                <a16:creationId xmlns:a16="http://schemas.microsoft.com/office/drawing/2014/main" id="{5A037FB3-FEDC-E88E-FBC7-7B6742E777C4}"/>
+              </a:ext>
+            </a:extLst>
+          </p:cNvPr>
+          <p:cNvSpPr txBox="1"/>
+          <p:nvPr/>
+        </p:nvSpPr>
+        <p:spPr>
+          <a:xfrm>
+            <a:off x="2087677" y="455054"/>
+            <a:ext cx="954000" cy="953478"/>
+          </a:xfrm>
+          <a:prstGeom prst="rect">
+            <a:avLst/>
+          </a:prstGeom>
+          <a:noFill/>
+        </p:spPr>
+        <p:txBody>
+          <a:bodyPr wrap="square" rtlCol="0" anchor="ctr">
+            <a:noAutofit/>
+          </a:bodyPr>
+          <a:lstStyle/>
+          <a:p>
+            <a:pPr algn="ctr"/>
+            <a:r>
+              <a:rPr lang="es-PE" dirty="0">
+                <a:solidFill>
+                  <a:schemeClr val="bg1"/>
+                </a:solidFill>
+              </a:rPr>
+              <a:t>{avatar}</a:t>
             </a:r>
           </a:p>
         </p:txBody>

</xml_diff>